<commit_message>
Update environment to notebook i7 16GB, add CSV links to README
Environment now reflects notebook with Intel Core i7-1255U, 16 GB DDR4,
Ubuntu 22.04. README includes links to per-language CSV result files
and detailed compiler/runtime versions.

Co-Authored-By: Claude Opus 4.6 <noreply@anthropic.com>
Claude-Session: https://claude.ai/code/session_01DFmbvmkS3voB3SQYq73gde
</commit_message>
<xml_diff>
--- a/results/Semana2_Benchmark_Matrices.pptx
+++ b/results/Semana2_Benchmark_Matrices.pptx
@@ -122,17 +122,17 @@
   <p:extLst>
     <p:ext uri="{521415D9-36F7-43E2-AB2F-B90AF26B5E84}">
       <p14:sectionLst xmlns:p14="http://schemas.microsoft.com/office/powerpoint/2010/main">
-        <p14:section name="Portada" id="{182454ba-7c25-3ff5-aa32-0d07c0f41c22}">
+        <p14:section name="Portada" id="{dcef1fa8-997c-0e7e-d170-9acc98343e44}">
           <p14:sldIdLst>
             <p14:sldId id="256"/>
           </p14:sldIdLst>
         </p14:section>
-        <p14:section name="Agenda" id="{0923f082-0f07-d5bd-3d6e-59891908e0c9}">
+        <p14:section name="Agenda" id="{9114e0d2-ca5d-be9f-f047-e91fef5dd703}">
           <p14:sldIdLst>
             <p14:sldId id="257"/>
           </p14:sldIdLst>
         </p14:section>
-        <p14:section name="Implementaciones" id="{f3297b1d-bbb5-3b76-2352-3e65e1d15353}">
+        <p14:section name="Implementaciones" id="{7dbdc8ba-7c18-c705-a0d3-3c2b70bf7422}">
           <p14:sldIdLst>
             <p14:sldId id="258"/>
             <p14:sldId id="259"/>
@@ -140,20 +140,20 @@
             <p14:sldId id="261"/>
           </p14:sldIdLst>
         </p14:section>
-        <p14:section name="Decisiones de Diseno" id="{3d577777-c20d-e86c-e005-f25e65b47d95}">
+        <p14:section name="Decisiones de Diseno" id="{161745a9-40a2-8ae1-9290-532436ae3aa4}">
           <p14:sldIdLst>
             <p14:sldId id="262"/>
             <p14:sldId id="263"/>
             <p14:sldId id="264"/>
           </p14:sldIdLst>
         </p14:section>
-        <p14:section name="Entorno" id="{0b2486ff-79e9-ce48-e948-b641900e7489}">
+        <p14:section name="Entorno" id="{dfe858fa-6927-83cf-d263-7190d22a9314}">
           <p14:sldIdLst>
             <p14:sldId id="265"/>
             <p14:sldId id="266"/>
           </p14:sldIdLst>
         </p14:section>
-        <p14:section name="Resultados" id="{d686d999-8771-4ef6-f9e6-279480fe85bf}">
+        <p14:section name="Resultados" id="{51f9cfa5-df49-5448-454a-aa4f367f8fcb}">
           <p14:sldIdLst>
             <p14:sldId id="267"/>
             <p14:sldId id="268"/>
@@ -161,7 +161,7 @@
             <p14:sldId id="270"/>
           </p14:sldIdLst>
         </p14:section>
-        <p14:section name="Conclusiones" id="{2a0ef5a7-67e7-04b9-1f64-73a71744f17f}">
+        <p14:section name="Conclusiones" id="{97ce0a30-a967-e676-3f56-283f7673e582}">
           <p14:sldIdLst>
             <p14:sldId id="271"/>
           </p14:sldIdLst>
@@ -3702,8 +3702,8 @@
         </p:nvSpPr>
         <p:spPr>
           <a:xfrm>
-            <a:off x="640080" y="1737360"/>
-            <a:ext cx="3566160" cy="457200"/>
+            <a:off x="640080" y="1691640"/>
+            <a:ext cx="3566160" cy="411480"/>
           </a:xfrm>
           <a:prstGeom prst="rect">
             <a:avLst/>
@@ -3719,7 +3719,55 @@
               <a:buNone/>
             </a:pPr>
             <a:r>
-              <a:rPr lang="en-US" sz="1100" dirty="0">
+              <a:rPr lang="en-US" sz="1000" dirty="0">
+                <a:solidFill>
+                  <a:srgbClr val="1C7293"/>
+                </a:solidFill>
+              </a:rPr>
+              <a:t>Equipo
+</a:t>
+            </a:r>
+            <a:pPr indent="0" marL="0">
+              <a:buNone/>
+            </a:pPr>
+            <a:r>
+              <a:rPr lang="en-US" sz="1300" b="1" dirty="0">
+                <a:solidFill>
+                  <a:srgbClr val="1B2838"/>
+                </a:solidFill>
+              </a:rPr>
+              <a:t>Notebook</a:t>
+            </a:r>
+            <a:endParaRPr lang="en-US" sz="1000" dirty="0"/>
+          </a:p>
+        </p:txBody>
+      </p:sp>
+      <p:sp>
+        <p:nvSpPr>
+          <p:cNvPr id="6" name="Text 4"/>
+          <p:cNvSpPr txBox="1"/>
+          <p:nvPr/>
+        </p:nvSpPr>
+        <p:spPr>
+          <a:xfrm>
+            <a:off x="640080" y="2121408"/>
+            <a:ext cx="3566160" cy="411480"/>
+          </a:xfrm>
+          <a:prstGeom prst="rect">
+            <a:avLst/>
+          </a:prstGeom>
+          <a:noFill/>
+          <a:ln/>
+        </p:spPr>
+        <p:txBody>
+          <a:bodyPr wrap="square" lIns="0" tIns="0" rIns="0" bIns="0" rtlCol="0" anchor="ctr"/>
+          <a:lstStyle/>
+          <a:p>
+            <a:pPr indent="0" marL="0">
+              <a:buNone/>
+            </a:pPr>
+            <a:r>
+              <a:rPr lang="en-US" sz="1000" dirty="0">
                 <a:solidFill>
                   <a:srgbClr val="1C7293"/>
                 </a:solidFill>
@@ -3731,27 +3779,27 @@
               <a:buNone/>
             </a:pPr>
             <a:r>
-              <a:rPr lang="en-US" sz="1400" b="1" dirty="0">
+              <a:rPr lang="en-US" sz="1300" b="1" dirty="0">
                 <a:solidFill>
                   <a:srgbClr val="1B2838"/>
                 </a:solidFill>
               </a:rPr>
-              <a:t>Intel Xeon @ 2.80 GHz</a:t>
-            </a:r>
-            <a:endParaRPr lang="en-US" sz="1100" dirty="0"/>
-          </a:p>
-        </p:txBody>
-      </p:sp>
-      <p:sp>
-        <p:nvSpPr>
-          <p:cNvPr id="6" name="Text 4"/>
+              <a:t>Intel Core i7-1255U @ 2.60 GHz</a:t>
+            </a:r>
+            <a:endParaRPr lang="en-US" sz="1000" dirty="0"/>
+          </a:p>
+        </p:txBody>
+      </p:sp>
+      <p:sp>
+        <p:nvSpPr>
+          <p:cNvPr id="7" name="Text 5"/>
           <p:cNvSpPr txBox="1"/>
           <p:nvPr/>
         </p:nvSpPr>
         <p:spPr>
           <a:xfrm>
-            <a:off x="640080" y="2240280"/>
-            <a:ext cx="3566160" cy="457200"/>
+            <a:off x="640080" y="2551176"/>
+            <a:ext cx="3566160" cy="411480"/>
           </a:xfrm>
           <a:prstGeom prst="rect">
             <a:avLst/>
@@ -3767,7 +3815,7 @@
               <a:buNone/>
             </a:pPr>
             <a:r>
-              <a:rPr lang="en-US" sz="1100" dirty="0">
+              <a:rPr lang="en-US" sz="1000" dirty="0">
                 <a:solidFill>
                   <a:srgbClr val="1C7293"/>
                 </a:solidFill>
@@ -3779,27 +3827,27 @@
               <a:buNone/>
             </a:pPr>
             <a:r>
-              <a:rPr lang="en-US" sz="1400" b="1" dirty="0">
+              <a:rPr lang="en-US" sz="1300" b="1" dirty="0">
                 <a:solidFill>
                   <a:srgbClr val="1B2838"/>
                 </a:solidFill>
               </a:rPr>
-              <a:t>8 GB</a:t>
-            </a:r>
-            <a:endParaRPr lang="en-US" sz="1100" dirty="0"/>
-          </a:p>
-        </p:txBody>
-      </p:sp>
-      <p:sp>
-        <p:nvSpPr>
-          <p:cNvPr id="7" name="Text 5"/>
+              <a:t>16 GB DDR4</a:t>
+            </a:r>
+            <a:endParaRPr lang="en-US" sz="1000" dirty="0"/>
+          </a:p>
+        </p:txBody>
+      </p:sp>
+      <p:sp>
+        <p:nvSpPr>
+          <p:cNvPr id="8" name="Text 6"/>
           <p:cNvSpPr txBox="1"/>
           <p:nvPr/>
         </p:nvSpPr>
         <p:spPr>
           <a:xfrm>
-            <a:off x="640080" y="2743200"/>
-            <a:ext cx="3566160" cy="457200"/>
+            <a:off x="640080" y="2980944"/>
+            <a:ext cx="3566160" cy="411480"/>
           </a:xfrm>
           <a:prstGeom prst="rect">
             <a:avLst/>
@@ -3815,7 +3863,7 @@
               <a:buNone/>
             </a:pPr>
             <a:r>
-              <a:rPr lang="en-US" sz="1100" dirty="0">
+              <a:rPr lang="en-US" sz="1000" dirty="0">
                 <a:solidFill>
                   <a:srgbClr val="1C7293"/>
                 </a:solidFill>
@@ -3827,27 +3875,27 @@
               <a:buNone/>
             </a:pPr>
             <a:r>
-              <a:rPr lang="en-US" sz="1400" b="1" dirty="0">
+              <a:rPr lang="en-US" sz="1300" b="1" dirty="0">
                 <a:solidFill>
                   <a:srgbClr val="1B2838"/>
                 </a:solidFill>
               </a:rPr>
-              <a:t>Linux 6.18.44</a:t>
-            </a:r>
-            <a:endParaRPr lang="en-US" sz="1100" dirty="0"/>
-          </a:p>
-        </p:txBody>
-      </p:sp>
-      <p:sp>
-        <p:nvSpPr>
-          <p:cNvPr id="8" name="Text 6"/>
+              <a:t>Ubuntu 22.04.4 LTS</a:t>
+            </a:r>
+            <a:endParaRPr lang="en-US" sz="1000" dirty="0"/>
+          </a:p>
+        </p:txBody>
+      </p:sp>
+      <p:sp>
+        <p:nvSpPr>
+          <p:cNvPr id="9" name="Text 7"/>
           <p:cNvSpPr txBox="1"/>
           <p:nvPr/>
         </p:nvSpPr>
         <p:spPr>
           <a:xfrm>
-            <a:off x="640080" y="3246120"/>
-            <a:ext cx="3566160" cy="457200"/>
+            <a:off x="640080" y="3410712"/>
+            <a:ext cx="3566160" cy="411480"/>
           </a:xfrm>
           <a:prstGeom prst="rect">
             <a:avLst/>
@@ -3863,7 +3911,7 @@
               <a:buNone/>
             </a:pPr>
             <a:r>
-              <a:rPr lang="en-US" sz="1100" dirty="0">
+              <a:rPr lang="en-US" sz="1000" dirty="0">
                 <a:solidFill>
                   <a:srgbClr val="1C7293"/>
                 </a:solidFill>
@@ -3875,27 +3923,27 @@
               <a:buNone/>
             </a:pPr>
             <a:r>
-              <a:rPr lang="en-US" sz="1400" b="1" dirty="0">
+              <a:rPr lang="en-US" sz="1300" b="1" dirty="0">
                 <a:solidFill>
                   <a:srgbClr val="1B2838"/>
                 </a:solidFill>
               </a:rPr>
               <a:t>x86_64</a:t>
             </a:r>
-            <a:endParaRPr lang="en-US" sz="1100" dirty="0"/>
-          </a:p>
-        </p:txBody>
-      </p:sp>
-      <p:sp>
-        <p:nvSpPr>
-          <p:cNvPr id="9" name="Text 7"/>
+            <a:endParaRPr lang="en-US" sz="1000" dirty="0"/>
+          </a:p>
+        </p:txBody>
+      </p:sp>
+      <p:sp>
+        <p:nvSpPr>
+          <p:cNvPr id="10" name="Text 8"/>
           <p:cNvSpPr txBox="1"/>
           <p:nvPr/>
         </p:nvSpPr>
         <p:spPr>
           <a:xfrm>
-            <a:off x="640080" y="3749040"/>
-            <a:ext cx="3566160" cy="457200"/>
+            <a:off x="640080" y="3840480"/>
+            <a:ext cx="3566160" cy="411480"/>
           </a:xfrm>
           <a:prstGeom prst="rect">
             <a:avLst/>
@@ -3911,7 +3959,7 @@
               <a:buNone/>
             </a:pPr>
             <a:r>
-              <a:rPr lang="en-US" sz="1100" dirty="0">
+              <a:rPr lang="en-US" sz="1000" dirty="0">
                 <a:solidFill>
                   <a:srgbClr val="1C7293"/>
                 </a:solidFill>
@@ -3923,20 +3971,20 @@
               <a:buNone/>
             </a:pPr>
             <a:r>
-              <a:rPr lang="en-US" sz="1400" b="1" dirty="0">
+              <a:rPr lang="en-US" sz="1300" b="1" dirty="0">
                 <a:solidFill>
                   <a:srgbClr val="1B2838"/>
                 </a:solidFill>
               </a:rPr>
               <a:t>29.8.2</a:t>
             </a:r>
-            <a:endParaRPr lang="en-US" sz="1100" dirty="0"/>
-          </a:p>
-        </p:txBody>
-      </p:sp>
-      <p:sp>
-        <p:nvSpPr>
-          <p:cNvPr id="10" name="Shape 8"/>
+            <a:endParaRPr lang="en-US" sz="1000" dirty="0"/>
+          </a:p>
+        </p:txBody>
+      </p:sp>
+      <p:sp>
+        <p:nvSpPr>
+          <p:cNvPr id="11" name="Shape 9"/>
           <p:cNvSpPr/>
           <p:nvPr/>
         </p:nvSpPr>
@@ -3958,7 +4006,7 @@
       </p:sp>
       <p:sp>
         <p:nvSpPr>
-          <p:cNvPr id="11" name="Text 9"/>
+          <p:cNvPr id="12" name="Text 10"/>
           <p:cNvSpPr txBox="1"/>
           <p:nvPr/>
         </p:nvSpPr>
@@ -3994,7 +4042,7 @@
       </p:sp>
       <p:sp>
         <p:nvSpPr>
-          <p:cNvPr id="12" name="Shape 10"/>
+          <p:cNvPr id="13" name="Shape 11"/>
           <p:cNvSpPr/>
           <p:nvPr/>
         </p:nvSpPr>
@@ -4016,7 +4064,7 @@
       </p:sp>
       <p:sp>
         <p:nvSpPr>
-          <p:cNvPr id="13" name="Text 11"/>
+          <p:cNvPr id="14" name="Text 12"/>
           <p:cNvSpPr txBox="1"/>
           <p:nvPr/>
         </p:nvSpPr>
@@ -4078,7 +4126,7 @@
       </p:sp>
       <p:sp>
         <p:nvSpPr>
-          <p:cNvPr id="14" name="Shape 12"/>
+          <p:cNvPr id="15" name="Shape 13"/>
           <p:cNvSpPr/>
           <p:nvPr/>
         </p:nvSpPr>
@@ -4100,7 +4148,7 @@
       </p:sp>
       <p:sp>
         <p:nvSpPr>
-          <p:cNvPr id="15" name="Text 13"/>
+          <p:cNvPr id="16" name="Text 14"/>
           <p:cNvSpPr txBox="1"/>
           <p:nvPr/>
         </p:nvSpPr>
@@ -4162,7 +4210,7 @@
       </p:sp>
       <p:sp>
         <p:nvSpPr>
-          <p:cNvPr id="16" name="Shape 14"/>
+          <p:cNvPr id="17" name="Shape 15"/>
           <p:cNvSpPr/>
           <p:nvPr/>
         </p:nvSpPr>
@@ -4184,7 +4232,7 @@
       </p:sp>
       <p:sp>
         <p:nvSpPr>
-          <p:cNvPr id="17" name="Text 15"/>
+          <p:cNvPr id="18" name="Text 16"/>
           <p:cNvSpPr txBox="1"/>
           <p:nvPr/>
         </p:nvSpPr>
@@ -4246,7 +4294,7 @@
       </p:sp>
       <p:sp>
         <p:nvSpPr>
-          <p:cNvPr id="18" name="Shape 16"/>
+          <p:cNvPr id="19" name="Shape 17"/>
           <p:cNvSpPr/>
           <p:nvPr/>
         </p:nvSpPr>
@@ -4268,7 +4316,7 @@
       </p:sp>
       <p:sp>
         <p:nvSpPr>
-          <p:cNvPr id="19" name="Text 17"/>
+          <p:cNvPr id="20" name="Text 18"/>
           <p:cNvSpPr txBox="1"/>
           <p:nvPr/>
         </p:nvSpPr>

</xml_diff>

<commit_message>
docs(semana2): agregar notas del presentador con guion narrativo
Cada slide tiene ahora notas con frases simples que guían
la presentación de forma lógica: transiciones entre secciones,
qué destacar en cada gráfico y cómo cerrar con ANOVA/Tukey
como próximos pasos.

Co-Authored-By: Claude Opus 4.6 <noreply@anthropic.com>
Claude-Session: https://claude.ai/code/session_01DFmbvmkS3voB3SQYq73gde
</commit_message>
<xml_diff>
--- a/results/Semana2_Benchmark_Matrices.pptx
+++ b/results/Semana2_Benchmark_Matrices.pptx
@@ -129,24 +129,24 @@
   <p:extLst>
     <p:ext uri="{521415D9-36F7-43E2-AB2F-B90AF26B5E84}">
       <p14:sectionLst xmlns:p14="http://schemas.microsoft.com/office/powerpoint/2010/main">
-        <p14:section name="Portada" id="{fa154510-6b5f-2bf1-7375-79e195144455}">
+        <p14:section name="Portada" id="{d4304068-c95a-8dd3-0785-7f764847010e}">
           <p14:sldIdLst>
             <p14:sldId id="256"/>
           </p14:sldIdLst>
         </p14:section>
-        <p14:section name="Agenda" id="{cd590c38-ab10-c0d4-07a7-ea678a699dd2}">
+        <p14:section name="Agenda" id="{553dc4b0-2cbc-b281-3f3f-e6e9c3a384e2}">
           <p14:sldIdLst>
             <p14:sldId id="257"/>
           </p14:sldIdLst>
         </p14:section>
-        <p14:section name="Resumen Semana 1" id="{57e7d845-e287-4d91-1ed5-ab38205d67a3}">
+        <p14:section name="Resumen Semana 1" id="{ba0b9fe9-9c5e-172d-8051-5ae042017880}">
           <p14:sldIdLst>
             <p14:sldId id="258"/>
             <p14:sldId id="259"/>
             <p14:sldId id="260"/>
           </p14:sldIdLst>
         </p14:section>
-        <p14:section name="Implementaciones" id="{94dad6c7-71d5-311d-16a3-4ce5c0797d3a}">
+        <p14:section name="Implementaciones" id="{5e317382-e52d-3487-b511-bafe4cb24ece}">
           <p14:sldIdLst>
             <p14:sldId id="261"/>
             <p14:sldId id="262"/>
@@ -154,20 +154,20 @@
             <p14:sldId id="264"/>
           </p14:sldIdLst>
         </p14:section>
-        <p14:section name="Decisiones de Diseno" id="{75dd5181-7add-d02a-e4de-2e3ddeace8dc}">
+        <p14:section name="Decisiones de Diseno" id="{91112fb1-68b4-7627-7855-f35ebd1f23fa}">
           <p14:sldIdLst>
             <p14:sldId id="265"/>
             <p14:sldId id="266"/>
             <p14:sldId id="267"/>
           </p14:sldIdLst>
         </p14:section>
-        <p14:section name="Entorno" id="{827eeb0f-2b79-7b63-20c0-f3bd509203c7}">
+        <p14:section name="Entorno" id="{7048b338-f052-3153-d84a-56e279959fed}">
           <p14:sldIdLst>
             <p14:sldId id="268"/>
             <p14:sldId id="269"/>
           </p14:sldIdLst>
         </p14:section>
-        <p14:section name="Resultados" id="{c50dac63-d7e1-85dd-78aa-bbfdec595b16}">
+        <p14:section name="Resultados" id="{ad521a8c-81e9-4def-dbc2-86fe222ccf80}">
           <p14:sldIdLst>
             <p14:sldId id="270"/>
             <p14:sldId id="271"/>
@@ -179,7 +179,7 @@
             <p14:sldId id="277"/>
           </p14:sldIdLst>
         </p14:section>
-        <p14:section name="Conclusiones" id="{d608aa8f-d77a-c0d9-8f4c-3f963d064ae0}">
+        <p14:section name="Conclusiones" id="{df56ac5d-39db-629f-5a68-6d275af68ad3}">
           <p14:sldIdLst>
             <p14:sldId id="278"/>
           </p14:sldIdLst>
@@ -1123,7 +1123,7 @@
           <a:p>
             <a:r>
               <a:rPr lang="en-US" dirty="0"/>
-              <a:t>Presentar el objetivo: implementar multiplicación naive de matrices en 4 lenguajes y obtener primeros resultados de benchmark.</a:t>
+              <a:t>Bienvenidos. En esta presentación mostramos el trabajo de Semana 2: la implementación y ejecución del experimento de benchmark de multiplicación de matrices. Partimos con un breve resumen de lo definido en Semana 1 y luego entramos de lleno en el código, las decisiones de diseño y los primeros resultados.</a:t>
             </a:r>
             <a:endParaRPr lang="en-US" dirty="0"/>
           </a:p>
@@ -1211,7 +1211,7 @@
           <a:p>
             <a:r>
               <a:rPr lang="en-US" dirty="0"/>
-              <a:t/>
+              <a:t>Para que la comparación entre lenguajes sea válida, tomamos varias decisiones de diseño que controlan las variables confusoras. Veamos cuáles y por qué.</a:t>
             </a:r>
             <a:endParaRPr lang="en-US" dirty="0"/>
           </a:p>
@@ -1299,7 +1299,7 @@
           <a:p>
             <a:r>
               <a:rPr lang="en-US" dirty="0"/>
-              <a:t>Tres decisiones clave: Docker para aislamiento, -O0 para no beneficiar a C++, y medir solo la multiplicación.</a:t>
+              <a:t>Tres decisiones fundamentales. Primero, Docker: cada lenguaje corre en su imagen oficial, eliminando conflictos de dependencias. Segundo, compilar C++ con -O0 para que el compilador no optimice el algoritmo y la comparación sea del lenguaje puro. Tercero, medir solo la multiplicación, excluyendo la generación de matrices para eliminar varianza por I/O.</a:t>
             </a:r>
             <a:endParaRPr lang="en-US" dirty="0"/>
           </a:p>
@@ -1387,7 +1387,7 @@
           <a:p>
             <a:r>
               <a:rPr lang="en-US" dirty="0"/>
-              <a:t>Snakemake automatiza todo el pipeline. El formato CSV estándar con 4 columnas facilita el análisis posterior.</a:t>
+              <a:t>Todo el flujo está automatizado con Snakemake: desde construir las imágenes Docker hasta generar el CSV consolidado. El formato de salida es simple: 4 columnas, 120 filas. Esto facilita el análisis estadístico que haremos en semanas posteriores. Veamos ahora en qué máquina corrimos el experimento.</a:t>
             </a:r>
             <a:endParaRPr lang="en-US" dirty="0"/>
           </a:p>
@@ -1475,7 +1475,7 @@
           <a:p>
             <a:r>
               <a:rPr lang="en-US" dirty="0"/>
-              <a:t/>
+              <a:t>Documentar el entorno es requisito para la reproducibilidad. Cualquier persona que quiera replicar debe saber exactamente en qué hardware y software se ejecutó.</a:t>
             </a:r>
             <a:endParaRPr lang="en-US" dirty="0"/>
           </a:p>
@@ -1563,7 +1563,7 @@
           <a:p>
             <a:r>
               <a:rPr lang="en-US" dirty="0"/>
-              <a:t>Documentar el entorno es clave para la reproducibilidad. Imágenes Docker oficiales con versiones fijas.</a:t>
+              <a:t>Un notebook con i7-1255U y 16 GB de RAM corriendo Ubuntu. Cada lenguaje usa su imagen Docker oficial con versiones fijas: gcc 13 para C++, golang 1.22, eclipse-temurin 21 para Java, y python 3.12-slim. Esto asegura que cualquiera pueda replicar el experimento con el mismo entorno. Ahora pasemos a lo más interesante: los resultados.</a:t>
             </a:r>
             <a:endParaRPr lang="en-US" dirty="0"/>
           </a:p>
@@ -1651,7 +1651,7 @@
           <a:p>
             <a:r>
               <a:rPr lang="en-US" dirty="0"/>
-              <a:t/>
+              <a:t>Llegamos a los primeros resultados. Todo lo que mostraremos aquí es análisis descriptivo: medias, desviaciones, gráficos de distribución. El análisis inferencial con ANOVA y Tukey lo haremos en Semana 4.</a:t>
             </a:r>
             <a:endParaRPr lang="en-US" dirty="0"/>
           </a:p>
@@ -1739,7 +1739,7 @@
           <a:p>
             <a:r>
               <a:rPr lang="en-US" dirty="0"/>
-              <a:t>Tabla resumen de estadísticas descriptivas. Go y Java lideran, Python es el más lento. C++ con -O0 no puede optimizar.</a:t>
+              <a:t>Aquí tenemos la tabla completa con media y desviación estándar por cada combinación lenguaje-tamaño. Tres cosas saltan a la vista: Go y Java son los más rápidos, C++ con -O0 queda en el medio, y Python es muy lento. Fíjense que las desviaciones estándar son pequeñas, lo que indica mediciones estables.</a:t>
             </a:r>
             <a:endParaRPr lang="en-US" dirty="0"/>
           </a:p>
@@ -1827,7 +1827,7 @@
           <a:p>
             <a:r>
               <a:rPr lang="en-US" dirty="0"/>
-              <a:t>Gráfico de barras agrupado mostrando tiempos medios. Python domina visualmente por sus tiempos mucho mayores.</a:t>
+              <a:t>Este gráfico de barras muestra visualmente lo que vimos en la tabla. Noten cómo Python domina la escala, haciendo que las barras de Go y Java casi no se vean en N=1500. Esto sugiere diferencias muy grandes, pero necesitamos cuantificarlo mejor.</a:t>
             </a:r>
             <a:endParaRPr lang="en-US" dirty="0"/>
           </a:p>
@@ -1915,7 +1915,7 @@
           <a:p>
             <a:r>
               <a:rPr lang="en-US" dirty="0"/>
-              <a:t>Ratios de rendimiento para N=1500. La baja variabilidad confirma que el experimento es estable.</a:t>
+              <a:t>Aquí cuantificamos las diferencias para N=1500. Python es 16 veces más lento que Go, C++ sin optimizaciones es 4.6 veces más lento, y Java solo 1.3 veces. Además, todos los coeficientes de variación están bajo el 5%, confirmando que nuestras mediciones son estables y confiables.</a:t>
             </a:r>
             <a:endParaRPr lang="en-US" dirty="0"/>
           </a:p>
@@ -2003,7 +2003,7 @@
           <a:p>
             <a:r>
               <a:rPr lang="en-US" dirty="0"/>
-              <a:t>Boxplots separados por tamaño de matriz. Se observa baja variabilidad y outliers mínimos.</a:t>
+              <a:t>Los boxplots confirman lo que dijimos: baja dispersión en todos los grupos, medianas representativas y prácticamente sin outliers. Esto nos da confianza en que los datos son de buena calidad para un análisis estadístico posterior.</a:t>
             </a:r>
             <a:endParaRPr lang="en-US" dirty="0"/>
           </a:p>
@@ -2091,7 +2091,7 @@
           <a:p>
             <a:r>
               <a:rPr lang="en-US" dirty="0"/>
-              <a:t>Resumen de los temas a cubrir en esta presentación.</a:t>
+              <a:t>Estos son los 5 bloques que vamos a recorrer. Primero un resumen rápido de Semana 1 para dar contexto, después las implementaciones, las decisiones que tomamos para que la comparación sea justa, el entorno donde corrimos todo, y finalmente los primeros resultados con gráficos y observaciones.</a:t>
             </a:r>
             <a:endParaRPr lang="en-US" dirty="0"/>
           </a:p>
@@ -2179,7 +2179,7 @@
           <a:p>
             <a:r>
               <a:rPr lang="en-US" dirty="0"/>
-              <a:t>Las curvas NO son paralelas: la brecha entre Python y los demás se amplifica con N. Esto sugiere interacción entre factores, a confirmar con ANOVA en Semana 4.</a:t>
+              <a:t>Este gráfico es clave: muestra cómo el efecto del lenguaje cambia según el tamaño de la matriz. Las curvas NO son paralelas — la brecha entre Python y los demás se amplifica al crecer N. Esto sugiere una interacción entre los factores lenguaje y tamaño, que confirmaremos formalmente con ANOVA de dos factores en Semana 4.</a:t>
             </a:r>
             <a:endParaRPr lang="en-US" dirty="0"/>
           </a:p>
@@ -2267,7 +2267,7 @@
           <a:p>
             <a:r>
               <a:rPr lang="en-US" dirty="0"/>
-              <a:t>Izquierda: mapa de calor con tiempos absolutos. Derecha: speedup relativo a Python. Go y Java superan ampliamente a Python en todos los tamaños.</a:t>
+              <a:t>A la izquierda, el mapa de calor muestra los tiempos absolutos — los colores oscuros indican tiempos altos. Python en N=1500 alcanza 342 segundos. A la derecha, el speedup relativo a Python: Go llega a casi 40x más rápido en N=500. Estos gráficos complementan la tabla numérica con una vista más intuitiva.</a:t>
             </a:r>
             <a:endParaRPr lang="en-US" dirty="0"/>
           </a:p>
@@ -2355,7 +2355,7 @@
           <a:p>
             <a:r>
               <a:rPr lang="en-US" dirty="0"/>
-              <a:t>Gráfico de barras con barras de error (media ± desviación estándar). La baja dispersión confirma estabilidad experimental.</a:t>
+              <a:t>Finalmente, este gráfico con barras de error muestra media más/menos una desviación estándar. Las barras de error son pequeñas en todos los casos, lo que confirma una vez más la estabilidad del experimento. Con toda esta evidencia descriptiva, pasemos a las conclusiones.</a:t>
             </a:r>
             <a:endParaRPr lang="en-US" dirty="0"/>
           </a:p>
@@ -2443,7 +2443,7 @@
           <a:p>
             <a:r>
               <a:rPr lang="en-US" dirty="0"/>
-              <a:t>Conclusiones descriptivas y próximos pasos: ANOVA y Tukey HSD se aplicarán en Semana 4 para confirmar estadísticamente las diferencias observadas.</a:t>
+              <a:t>Para cerrar: descriptivamente, Go y Java lideran, C++ sin optimizaciones queda en medio, y Python es consistentemente el más lento. Pero estas son observaciones descriptivas. Para poder afirmar que las diferencias son estadísticamente significativas necesitamos ANOVA de dos factores, y para saber exactamente cuáles pares difieren, Tukey HSD. Eso viene en Semana 4, junto con la automatización completa con Snakemake. Gracias.</a:t>
             </a:r>
             <a:endParaRPr lang="en-US" dirty="0"/>
           </a:p>
@@ -2531,7 +2531,7 @@
           <a:p>
             <a:r>
               <a:rPr lang="en-US" dirty="0"/>
-              <a:t/>
+              <a:t>Antes de entrar en la implementación, recordemos brevemente qué definimos en Semana 1: la pregunta de investigación, las hipótesis y las variables del experimento.</a:t>
             </a:r>
             <a:endParaRPr lang="en-US" dirty="0"/>
           </a:p>
@@ -2619,7 +2619,7 @@
           <a:p>
             <a:r>
               <a:rPr lang="en-US" dirty="0"/>
-              <a:t>Resumen del diseño experimental definido en Semana 1: pregunta, hipótesis, variables y plan de 120 observaciones.</a:t>
+              <a:t>Nuestra pregunta es si existen diferencias significativas entre los 4 lenguajes. Tenemos dos factores independientes —lenguaje y tamaño—, una variable dependiente —el tiempo—, y controles como la semilla fija y 10 repeticiones. En total son 120 mediciones. Con esto claro, pasamos a ver cómo se organizó el repositorio.</a:t>
             </a:r>
             <a:endParaRPr lang="en-US" dirty="0"/>
           </a:p>
@@ -2707,7 +2707,7 @@
           <a:p>
             <a:r>
               <a:rPr lang="en-US" dirty="0"/>
-              <a:t>Repositorio creado en GitHub con README.md que documenta el diseño experimental, siguiendo ACM Artifact Review &amp; Badging.</a:t>
+              <a:t>Todo el proyecto vive en GitHub. El README documenta el diseño experimental completo, las instrucciones de reproducción y el entorno. Seguimos el marco ACM Artifact Review and Badging para ir hacia los badges Functional, Reusable y Available. Con el contexto de Semana 1 claro, pasemos ahora a las implementaciones.</a:t>
             </a:r>
             <a:endParaRPr lang="en-US" dirty="0"/>
           </a:p>
@@ -2795,7 +2795,7 @@
           <a:p>
             <a:r>
               <a:rPr lang="en-US" dirty="0"/>
-              <a:t/>
+              <a:t>Entramos en el corazón de Semana 2: qué algoritmo implementamos, en qué lenguajes y cómo garantizamos que las matrices sean idénticas en todos.</a:t>
             </a:r>
             <a:endParaRPr lang="en-US" dirty="0"/>
           </a:p>
@@ -2883,7 +2883,7 @@
           <a:p>
             <a:r>
               <a:rPr lang="en-US" dirty="0"/>
-              <a:t>Algoritmo naive: triple bucle, sin optimizaciones. El mismo algoritmo se implementa de forma idéntica en los 4 lenguajes.</a:t>
+              <a:t>Usamos el algoritmo naive de triple bucle: complejidad O(n³), sin optimizaciones de cache, SIMD ni paralelismo. Esto es deliberado: queremos medir el lenguaje, no trucos de optimización. Veamos ahora cómo se ve en cada lenguaje.</a:t>
             </a:r>
             <a:endParaRPr lang="en-US" dirty="0"/>
           </a:p>
@@ -2971,7 +2971,7 @@
           <a:p>
             <a:r>
               <a:rPr lang="en-US" dirty="0"/>
-              <a:t>Cada implementación usa el mismo algoritmo naive con triple bucle. Las diferencias son sintácticas.</a:t>
+              <a:t>Cuatro lenguajes, un solo algoritmo. Las diferencias son solo sintácticas: cada uno usa su tipo nativo de arreglo bidimensional y su función de medición de tiempo. Ahora, ¿cómo aseguramos que las matrices de entrada sean exactamente las mismas?</a:t>
             </a:r>
             <a:endParaRPr lang="en-US" dirty="0"/>
           </a:p>
@@ -3059,7 +3059,7 @@
           <a:p>
             <a:r>
               <a:rPr lang="en-US" dirty="0"/>
-              <a:t>El generador lineal congruencial (LCG) asegura reproducibilidad: mismas semillas = mismas matrices = mismos resultados.</a:t>
+              <a:t>La clave de la reproducibilidad es el generador LCG con semilla fija 42. Al implementar el mismo generador en los 4 lenguajes, garantizamos que las matrices A y B son idénticas bit a bit. Así cualquier diferencia de tiempo es atribuible al lenguaje, no a los datos. Ahora veamos las decisiones de diseño para que la comparación sea justa.</a:t>
             </a:r>
             <a:endParaRPr lang="en-US" dirty="0"/>
           </a:p>

</xml_diff>